<commit_message>
Modification du diagramme de classes
</commit_message>
<xml_diff>
--- a/Documents/Diagrammes/Diagrammes_classes.pptx
+++ b/Documents/Diagrammes/Diagrammes_classes.pptx
@@ -104,6 +104,11 @@
       </a:defRPr>
     </a:lvl9pPr>
   </p:defaultTextStyle>
+  <p:extLst>
+    <p:ext uri="{EFAFB233-063F-42B5-8137-9DF3F51BA10A}">
+      <p15:sldGuideLst xmlns:p15="http://schemas.microsoft.com/office/powerpoint/2012/main"/>
+    </p:ext>
+  </p:extLst>
 </p:presentation>
 </file>
 
@@ -254,7 +259,7 @@
           <a:p>
             <a:fld id="{DA9B3332-0F0C-4BB6-B573-ADD4F1961A19}" type="datetimeFigureOut">
               <a:rPr lang="fr-FR" smtClean="0"/>
-              <a:t>01/10/2024</a:t>
+              <a:t>17/12/2024</a:t>
             </a:fld>
             <a:endParaRPr lang="fr-FR"/>
           </a:p>
@@ -452,7 +457,7 @@
           <a:p>
             <a:fld id="{DA9B3332-0F0C-4BB6-B573-ADD4F1961A19}" type="datetimeFigureOut">
               <a:rPr lang="fr-FR" smtClean="0"/>
-              <a:t>01/10/2024</a:t>
+              <a:t>17/12/2024</a:t>
             </a:fld>
             <a:endParaRPr lang="fr-FR"/>
           </a:p>
@@ -660,7 +665,7 @@
           <a:p>
             <a:fld id="{DA9B3332-0F0C-4BB6-B573-ADD4F1961A19}" type="datetimeFigureOut">
               <a:rPr lang="fr-FR" smtClean="0"/>
-              <a:t>01/10/2024</a:t>
+              <a:t>17/12/2024</a:t>
             </a:fld>
             <a:endParaRPr lang="fr-FR"/>
           </a:p>
@@ -858,7 +863,7 @@
           <a:p>
             <a:fld id="{DA9B3332-0F0C-4BB6-B573-ADD4F1961A19}" type="datetimeFigureOut">
               <a:rPr lang="fr-FR" smtClean="0"/>
-              <a:t>01/10/2024</a:t>
+              <a:t>17/12/2024</a:t>
             </a:fld>
             <a:endParaRPr lang="fr-FR"/>
           </a:p>
@@ -1133,7 +1138,7 @@
           <a:p>
             <a:fld id="{DA9B3332-0F0C-4BB6-B573-ADD4F1961A19}" type="datetimeFigureOut">
               <a:rPr lang="fr-FR" smtClean="0"/>
-              <a:t>01/10/2024</a:t>
+              <a:t>17/12/2024</a:t>
             </a:fld>
             <a:endParaRPr lang="fr-FR"/>
           </a:p>
@@ -1398,7 +1403,7 @@
           <a:p>
             <a:fld id="{DA9B3332-0F0C-4BB6-B573-ADD4F1961A19}" type="datetimeFigureOut">
               <a:rPr lang="fr-FR" smtClean="0"/>
-              <a:t>01/10/2024</a:t>
+              <a:t>17/12/2024</a:t>
             </a:fld>
             <a:endParaRPr lang="fr-FR"/>
           </a:p>
@@ -1810,7 +1815,7 @@
           <a:p>
             <a:fld id="{DA9B3332-0F0C-4BB6-B573-ADD4F1961A19}" type="datetimeFigureOut">
               <a:rPr lang="fr-FR" smtClean="0"/>
-              <a:t>01/10/2024</a:t>
+              <a:t>17/12/2024</a:t>
             </a:fld>
             <a:endParaRPr lang="fr-FR"/>
           </a:p>
@@ -1951,7 +1956,7 @@
           <a:p>
             <a:fld id="{DA9B3332-0F0C-4BB6-B573-ADD4F1961A19}" type="datetimeFigureOut">
               <a:rPr lang="fr-FR" smtClean="0"/>
-              <a:t>01/10/2024</a:t>
+              <a:t>17/12/2024</a:t>
             </a:fld>
             <a:endParaRPr lang="fr-FR"/>
           </a:p>
@@ -2064,7 +2069,7 @@
           <a:p>
             <a:fld id="{DA9B3332-0F0C-4BB6-B573-ADD4F1961A19}" type="datetimeFigureOut">
               <a:rPr lang="fr-FR" smtClean="0"/>
-              <a:t>01/10/2024</a:t>
+              <a:t>17/12/2024</a:t>
             </a:fld>
             <a:endParaRPr lang="fr-FR"/>
           </a:p>
@@ -2375,7 +2380,7 @@
           <a:p>
             <a:fld id="{DA9B3332-0F0C-4BB6-B573-ADD4F1961A19}" type="datetimeFigureOut">
               <a:rPr lang="fr-FR" smtClean="0"/>
-              <a:t>01/10/2024</a:t>
+              <a:t>17/12/2024</a:t>
             </a:fld>
             <a:endParaRPr lang="fr-FR"/>
           </a:p>
@@ -2663,7 +2668,7 @@
           <a:p>
             <a:fld id="{DA9B3332-0F0C-4BB6-B573-ADD4F1961A19}" type="datetimeFigureOut">
               <a:rPr lang="fr-FR" smtClean="0"/>
-              <a:t>01/10/2024</a:t>
+              <a:t>17/12/2024</a:t>
             </a:fld>
             <a:endParaRPr lang="fr-FR"/>
           </a:p>
@@ -2904,7 +2909,7 @@
           <a:p>
             <a:fld id="{DA9B3332-0F0C-4BB6-B573-ADD4F1961A19}" type="datetimeFigureOut">
               <a:rPr lang="fr-FR" smtClean="0"/>
-              <a:t>01/10/2024</a:t>
+              <a:t>17/12/2024</a:t>
             </a:fld>
             <a:endParaRPr lang="fr-FR"/>
           </a:p>
@@ -3323,144 +3328,6 @@
       </p:grpSpPr>
       <p:sp>
         <p:nvSpPr>
-          <p:cNvPr id="6" name="Rectangle 5">
-            <a:extLst>
-              <a:ext uri="{FF2B5EF4-FFF2-40B4-BE49-F238E27FC236}">
-                <a16:creationId xmlns:a16="http://schemas.microsoft.com/office/drawing/2014/main" id="{35690F6E-4161-495F-8688-052C48001903}"/>
-              </a:ext>
-            </a:extLst>
-          </p:cNvPr>
-          <p:cNvSpPr/>
-          <p:nvPr/>
-        </p:nvSpPr>
-        <p:spPr>
-          <a:xfrm>
-            <a:off x="1464199" y="1267968"/>
-            <a:ext cx="1922320" cy="2434772"/>
-          </a:xfrm>
-          <a:prstGeom prst="rect">
-            <a:avLst/>
-          </a:prstGeom>
-          <a:solidFill>
-            <a:schemeClr val="bg1"/>
-          </a:solidFill>
-          <a:ln>
-            <a:solidFill>
-              <a:schemeClr val="tx1"/>
-            </a:solidFill>
-          </a:ln>
-        </p:spPr>
-        <p:style>
-          <a:lnRef idx="2">
-            <a:schemeClr val="accent1">
-              <a:shade val="50000"/>
-            </a:schemeClr>
-          </a:lnRef>
-          <a:fillRef idx="1">
-            <a:schemeClr val="accent1"/>
-          </a:fillRef>
-          <a:effectRef idx="0">
-            <a:schemeClr val="accent1"/>
-          </a:effectRef>
-          <a:fontRef idx="minor">
-            <a:schemeClr val="lt1"/>
-          </a:fontRef>
-        </p:style>
-        <p:txBody>
-          <a:bodyPr rtlCol="0" anchor="ctr"/>
-          <a:lstStyle/>
-          <a:p>
-            <a:pPr algn="ctr"/>
-            <a:endParaRPr lang="fr-FR" dirty="0">
-              <a:latin typeface="Arial" panose="020B0604020202020204" pitchFamily="34" charset="0"/>
-              <a:cs typeface="Arial" panose="020B0604020202020204" pitchFamily="34" charset="0"/>
-            </a:endParaRPr>
-          </a:p>
-        </p:txBody>
-      </p:sp>
-      <p:cxnSp>
-        <p:nvCxnSpPr>
-          <p:cNvPr id="8" name="Connecteur droit 7">
-            <a:extLst>
-              <a:ext uri="{FF2B5EF4-FFF2-40B4-BE49-F238E27FC236}">
-                <a16:creationId xmlns:a16="http://schemas.microsoft.com/office/drawing/2014/main" id="{50B5B435-EDB4-4839-A25C-72BF821E8802}"/>
-              </a:ext>
-            </a:extLst>
-          </p:cNvPr>
-          <p:cNvCxnSpPr>
-            <a:cxnSpLocks/>
-          </p:cNvCxnSpPr>
-          <p:nvPr/>
-        </p:nvCxnSpPr>
-        <p:spPr>
-          <a:xfrm>
-            <a:off x="1464199" y="1580388"/>
-            <a:ext cx="1922320" cy="0"/>
-          </a:xfrm>
-          <a:prstGeom prst="line">
-            <a:avLst/>
-          </a:prstGeom>
-          <a:ln w="12700">
-            <a:solidFill>
-              <a:schemeClr val="tx1"/>
-            </a:solidFill>
-          </a:ln>
-        </p:spPr>
-        <p:style>
-          <a:lnRef idx="1">
-            <a:schemeClr val="accent1"/>
-          </a:lnRef>
-          <a:fillRef idx="0">
-            <a:schemeClr val="accent1"/>
-          </a:fillRef>
-          <a:effectRef idx="0">
-            <a:schemeClr val="accent1"/>
-          </a:effectRef>
-          <a:fontRef idx="minor">
-            <a:schemeClr val="tx1"/>
-          </a:fontRef>
-        </p:style>
-      </p:cxnSp>
-      <p:sp>
-        <p:nvSpPr>
-          <p:cNvPr id="10" name="ZoneTexte 9">
-            <a:extLst>
-              <a:ext uri="{FF2B5EF4-FFF2-40B4-BE49-F238E27FC236}">
-                <a16:creationId xmlns:a16="http://schemas.microsoft.com/office/drawing/2014/main" id="{A0ED7C6D-B818-4656-9FC5-6CF044F850FE}"/>
-              </a:ext>
-            </a:extLst>
-          </p:cNvPr>
-          <p:cNvSpPr txBox="1"/>
-          <p:nvPr/>
-        </p:nvSpPr>
-        <p:spPr>
-          <a:xfrm>
-            <a:off x="1941892" y="1238385"/>
-            <a:ext cx="966931" cy="369332"/>
-          </a:xfrm>
-          <a:prstGeom prst="rect">
-            <a:avLst/>
-          </a:prstGeom>
-          <a:noFill/>
-        </p:spPr>
-        <p:txBody>
-          <a:bodyPr wrap="none" rtlCol="0">
-            <a:spAutoFit/>
-          </a:bodyPr>
-          <a:lstStyle/>
-          <a:p>
-            <a:r>
-              <a:rPr lang="fr-FR" dirty="0">
-                <a:latin typeface="Arial" panose="020B0604020202020204" pitchFamily="34" charset="0"/>
-                <a:cs typeface="Arial" panose="020B0604020202020204" pitchFamily="34" charset="0"/>
-              </a:rPr>
-              <a:t>Plateau</a:t>
-            </a:r>
-          </a:p>
-        </p:txBody>
-      </p:sp>
-      <p:sp>
-        <p:nvSpPr>
           <p:cNvPr id="11" name="Rectangle 10">
             <a:extLst>
               <a:ext uri="{FF2B5EF4-FFF2-40B4-BE49-F238E27FC236}">
@@ -3474,7 +3341,7 @@
         <p:spPr>
           <a:xfrm>
             <a:off x="5535168" y="1267968"/>
-            <a:ext cx="1969008" cy="1262852"/>
+            <a:ext cx="1969008" cy="1076926"/>
           </a:xfrm>
           <a:prstGeom prst="rect">
             <a:avLst/>
@@ -3612,7 +3479,7 @@
         <p:spPr>
           <a:xfrm>
             <a:off x="4227609" y="3246131"/>
-            <a:ext cx="1930425" cy="1189212"/>
+            <a:ext cx="1930425" cy="1233340"/>
           </a:xfrm>
           <a:prstGeom prst="rect">
             <a:avLst/>
@@ -3711,8 +3578,8 @@
         </p:nvSpPr>
         <p:spPr>
           <a:xfrm>
-            <a:off x="6889417" y="3246131"/>
-            <a:ext cx="1930424" cy="1188000"/>
+            <a:off x="6889417" y="3246130"/>
+            <a:ext cx="1930424" cy="1233341"/>
           </a:xfrm>
           <a:prstGeom prst="rect">
             <a:avLst/>
@@ -3839,65 +3706,639 @@
           </a:p>
         </p:txBody>
       </p:sp>
-      <p:cxnSp>
-        <p:nvCxnSpPr>
-          <p:cNvPr id="20" name="Connecteur droit 19">
-            <a:extLst>
-              <a:ext uri="{FF2B5EF4-FFF2-40B4-BE49-F238E27FC236}">
-                <a16:creationId xmlns:a16="http://schemas.microsoft.com/office/drawing/2014/main" id="{88358FC7-7EA0-43D1-BAD1-C4035DB1E490}"/>
-              </a:ext>
-            </a:extLst>
-          </p:cNvPr>
-          <p:cNvCxnSpPr>
-            <a:cxnSpLocks/>
-          </p:cNvCxnSpPr>
+      <p:grpSp>
+        <p:nvGrpSpPr>
+          <p:cNvPr id="29" name="Groupe 28">
+            <a:extLst>
+              <a:ext uri="{FF2B5EF4-FFF2-40B4-BE49-F238E27FC236}">
+                <a16:creationId xmlns:a16="http://schemas.microsoft.com/office/drawing/2014/main" id="{F540F139-D614-4E58-A6CB-58C14A2D83FB}"/>
+              </a:ext>
+            </a:extLst>
+          </p:cNvPr>
+          <p:cNvGrpSpPr/>
           <p:nvPr/>
-        </p:nvCxnSpPr>
+        </p:nvGrpSpPr>
+        <p:grpSpPr>
+          <a:xfrm>
+            <a:off x="713726" y="667850"/>
+            <a:ext cx="2652119" cy="4981895"/>
+            <a:chOff x="734400" y="395448"/>
+            <a:chExt cx="2652119" cy="4981895"/>
+          </a:xfrm>
+        </p:grpSpPr>
+        <p:sp>
+          <p:nvSpPr>
+            <p:cNvPr id="6" name="Rectangle 5">
+              <a:extLst>
+                <a:ext uri="{FF2B5EF4-FFF2-40B4-BE49-F238E27FC236}">
+                  <a16:creationId xmlns:a16="http://schemas.microsoft.com/office/drawing/2014/main" id="{35690F6E-4161-495F-8688-052C48001903}"/>
+                </a:ext>
+              </a:extLst>
+            </p:cNvPr>
+            <p:cNvSpPr/>
+            <p:nvPr/>
+          </p:nvSpPr>
+          <p:spPr>
+            <a:xfrm>
+              <a:off x="740342" y="395449"/>
+              <a:ext cx="2646177" cy="4981894"/>
+            </a:xfrm>
+            <a:prstGeom prst="rect">
+              <a:avLst/>
+            </a:prstGeom>
+            <a:solidFill>
+              <a:schemeClr val="bg1"/>
+            </a:solidFill>
+            <a:ln>
+              <a:solidFill>
+                <a:schemeClr val="tx1"/>
+              </a:solidFill>
+            </a:ln>
+          </p:spPr>
+          <p:style>
+            <a:lnRef idx="2">
+              <a:schemeClr val="accent1">
+                <a:shade val="50000"/>
+              </a:schemeClr>
+            </a:lnRef>
+            <a:fillRef idx="1">
+              <a:schemeClr val="accent1"/>
+            </a:fillRef>
+            <a:effectRef idx="0">
+              <a:schemeClr val="accent1"/>
+            </a:effectRef>
+            <a:fontRef idx="minor">
+              <a:schemeClr val="lt1"/>
+            </a:fontRef>
+          </p:style>
+          <p:txBody>
+            <a:bodyPr rtlCol="0" anchor="ctr"/>
+            <a:lstStyle/>
+            <a:p>
+              <a:pPr algn="ctr"/>
+              <a:endParaRPr lang="fr-FR" dirty="0">
+                <a:latin typeface="Arial" panose="020B0604020202020204" pitchFamily="34" charset="0"/>
+                <a:cs typeface="Arial" panose="020B0604020202020204" pitchFamily="34" charset="0"/>
+              </a:endParaRPr>
+            </a:p>
+          </p:txBody>
+        </p:sp>
+        <p:cxnSp>
+          <p:nvCxnSpPr>
+            <p:cNvPr id="8" name="Connecteur droit 7">
+              <a:extLst>
+                <a:ext uri="{FF2B5EF4-FFF2-40B4-BE49-F238E27FC236}">
+                  <a16:creationId xmlns:a16="http://schemas.microsoft.com/office/drawing/2014/main" id="{50B5B435-EDB4-4839-A25C-72BF821E8802}"/>
+                </a:ext>
+              </a:extLst>
+            </p:cNvPr>
+            <p:cNvCxnSpPr>
+              <a:cxnSpLocks/>
+            </p:cNvCxnSpPr>
+            <p:nvPr/>
+          </p:nvCxnSpPr>
+          <p:spPr>
+            <a:xfrm>
+              <a:off x="740342" y="764780"/>
+              <a:ext cx="2642224" cy="0"/>
+            </a:xfrm>
+            <a:prstGeom prst="line">
+              <a:avLst/>
+            </a:prstGeom>
+            <a:ln w="12700">
+              <a:solidFill>
+                <a:schemeClr val="tx1"/>
+              </a:solidFill>
+            </a:ln>
+          </p:spPr>
+          <p:style>
+            <a:lnRef idx="1">
+              <a:schemeClr val="accent1"/>
+            </a:lnRef>
+            <a:fillRef idx="0">
+              <a:schemeClr val="accent1"/>
+            </a:fillRef>
+            <a:effectRef idx="0">
+              <a:schemeClr val="accent1"/>
+            </a:effectRef>
+            <a:fontRef idx="minor">
+              <a:schemeClr val="tx1"/>
+            </a:fontRef>
+          </p:style>
+        </p:cxnSp>
+        <p:sp>
+          <p:nvSpPr>
+            <p:cNvPr id="10" name="ZoneTexte 9">
+              <a:extLst>
+                <a:ext uri="{FF2B5EF4-FFF2-40B4-BE49-F238E27FC236}">
+                  <a16:creationId xmlns:a16="http://schemas.microsoft.com/office/drawing/2014/main" id="{A0ED7C6D-B818-4656-9FC5-6CF044F850FE}"/>
+                </a:ext>
+              </a:extLst>
+            </p:cNvPr>
+            <p:cNvSpPr txBox="1"/>
+            <p:nvPr/>
+          </p:nvSpPr>
+          <p:spPr>
+            <a:xfrm>
+              <a:off x="1579964" y="395448"/>
+              <a:ext cx="966931" cy="369332"/>
+            </a:xfrm>
+            <a:prstGeom prst="rect">
+              <a:avLst/>
+            </a:prstGeom>
+            <a:noFill/>
+          </p:spPr>
+          <p:txBody>
+            <a:bodyPr wrap="none" rtlCol="0">
+              <a:spAutoFit/>
+            </a:bodyPr>
+            <a:lstStyle/>
+            <a:p>
+              <a:r>
+                <a:rPr lang="fr-FR" dirty="0">
+                  <a:latin typeface="Arial" panose="020B0604020202020204" pitchFamily="34" charset="0"/>
+                  <a:cs typeface="Arial" panose="020B0604020202020204" pitchFamily="34" charset="0"/>
+                </a:rPr>
+                <a:t>Plateau</a:t>
+              </a:r>
+            </a:p>
+          </p:txBody>
+        </p:sp>
+        <p:cxnSp>
+          <p:nvCxnSpPr>
+            <p:cNvPr id="20" name="Connecteur droit 19">
+              <a:extLst>
+                <a:ext uri="{FF2B5EF4-FFF2-40B4-BE49-F238E27FC236}">
+                  <a16:creationId xmlns:a16="http://schemas.microsoft.com/office/drawing/2014/main" id="{88358FC7-7EA0-43D1-BAD1-C4035DB1E490}"/>
+                </a:ext>
+              </a:extLst>
+            </p:cNvPr>
+            <p:cNvCxnSpPr>
+              <a:cxnSpLocks/>
+            </p:cNvCxnSpPr>
+            <p:nvPr/>
+          </p:nvCxnSpPr>
+          <p:spPr>
+            <a:xfrm>
+              <a:off x="735344" y="1840678"/>
+              <a:ext cx="2647222" cy="0"/>
+            </a:xfrm>
+            <a:prstGeom prst="line">
+              <a:avLst/>
+            </a:prstGeom>
+            <a:ln w="12700">
+              <a:solidFill>
+                <a:schemeClr val="tx1"/>
+              </a:solidFill>
+            </a:ln>
+          </p:spPr>
+          <p:style>
+            <a:lnRef idx="1">
+              <a:schemeClr val="accent1"/>
+            </a:lnRef>
+            <a:fillRef idx="0">
+              <a:schemeClr val="accent1"/>
+            </a:fillRef>
+            <a:effectRef idx="0">
+              <a:schemeClr val="accent1"/>
+            </a:effectRef>
+            <a:fontRef idx="minor">
+              <a:schemeClr val="tx1"/>
+            </a:fontRef>
+          </p:style>
+        </p:cxnSp>
+        <p:sp>
+          <p:nvSpPr>
+            <p:cNvPr id="21" name="ZoneTexte 20">
+              <a:extLst>
+                <a:ext uri="{FF2B5EF4-FFF2-40B4-BE49-F238E27FC236}">
+                  <a16:creationId xmlns:a16="http://schemas.microsoft.com/office/drawing/2014/main" id="{77DA9FB0-3C93-43A2-B171-E6DE7E6414B4}"/>
+                </a:ext>
+              </a:extLst>
+            </p:cNvPr>
+            <p:cNvSpPr txBox="1"/>
+            <p:nvPr/>
+          </p:nvSpPr>
+          <p:spPr>
+            <a:xfrm>
+              <a:off x="735344" y="760695"/>
+              <a:ext cx="1922320" cy="1077218"/>
+            </a:xfrm>
+            <a:prstGeom prst="rect">
+              <a:avLst/>
+            </a:prstGeom>
+            <a:noFill/>
+          </p:spPr>
+          <p:txBody>
+            <a:bodyPr wrap="square" rtlCol="0">
+              <a:spAutoFit/>
+            </a:bodyPr>
+            <a:lstStyle/>
+            <a:p>
+              <a:r>
+                <a:rPr lang="fr-FR" sz="1600" dirty="0">
+                  <a:latin typeface="Arial" panose="020B0604020202020204" pitchFamily="34" charset="0"/>
+                  <a:cs typeface="Arial" panose="020B0604020202020204" pitchFamily="34" charset="0"/>
+                </a:rPr>
+                <a:t>- atteint2048 : </a:t>
+              </a:r>
+              <a:r>
+                <a:rPr lang="fr-FR" sz="1600" dirty="0" err="1">
+                  <a:latin typeface="Arial" panose="020B0604020202020204" pitchFamily="34" charset="0"/>
+                  <a:cs typeface="Arial" panose="020B0604020202020204" pitchFamily="34" charset="0"/>
+                </a:rPr>
+                <a:t>bool</a:t>
+              </a:r>
+              <a:endParaRPr lang="fr-FR" sz="1600" dirty="0">
+                <a:latin typeface="Arial" panose="020B0604020202020204" pitchFamily="34" charset="0"/>
+                <a:cs typeface="Arial" panose="020B0604020202020204" pitchFamily="34" charset="0"/>
+              </a:endParaRPr>
+            </a:p>
+            <a:p>
+              <a:r>
+                <a:rPr lang="fr-FR" sz="1600" dirty="0">
+                  <a:latin typeface="Arial" panose="020B0604020202020204" pitchFamily="34" charset="0"/>
+                  <a:cs typeface="Arial" panose="020B0604020202020204" pitchFamily="34" charset="0"/>
+                </a:rPr>
+                <a:t>- cote : </a:t>
+              </a:r>
+              <a:r>
+                <a:rPr lang="fr-FR" sz="1600" dirty="0" err="1">
+                  <a:latin typeface="Arial" panose="020B0604020202020204" pitchFamily="34" charset="0"/>
+                  <a:cs typeface="Arial" panose="020B0604020202020204" pitchFamily="34" charset="0"/>
+                </a:rPr>
+                <a:t>int</a:t>
+              </a:r>
+              <a:endParaRPr lang="fr-FR" sz="1600" dirty="0">
+                <a:latin typeface="Arial" panose="020B0604020202020204" pitchFamily="34" charset="0"/>
+                <a:cs typeface="Arial" panose="020B0604020202020204" pitchFamily="34" charset="0"/>
+              </a:endParaRPr>
+            </a:p>
+            <a:p>
+              <a:r>
+                <a:rPr lang="fr-FR" sz="1600" dirty="0">
+                  <a:latin typeface="Arial" panose="020B0604020202020204" pitchFamily="34" charset="0"/>
+                  <a:cs typeface="Arial" panose="020B0604020202020204" pitchFamily="34" charset="0"/>
+                </a:rPr>
+                <a:t>- score : </a:t>
+              </a:r>
+              <a:r>
+                <a:rPr lang="fr-FR" sz="1600" dirty="0" err="1">
+                  <a:latin typeface="Arial" panose="020B0604020202020204" pitchFamily="34" charset="0"/>
+                  <a:cs typeface="Arial" panose="020B0604020202020204" pitchFamily="34" charset="0"/>
+                </a:rPr>
+                <a:t>int</a:t>
+              </a:r>
+              <a:endParaRPr lang="fr-FR" sz="1600" dirty="0">
+                <a:latin typeface="Arial" panose="020B0604020202020204" pitchFamily="34" charset="0"/>
+                <a:cs typeface="Arial" panose="020B0604020202020204" pitchFamily="34" charset="0"/>
+              </a:endParaRPr>
+            </a:p>
+            <a:p>
+              <a:r>
+                <a:rPr lang="fr-FR" sz="1600" dirty="0">
+                  <a:latin typeface="Arial" panose="020B0604020202020204" pitchFamily="34" charset="0"/>
+                  <a:cs typeface="Arial" panose="020B0604020202020204" pitchFamily="34" charset="0"/>
+                </a:rPr>
+                <a:t>- </a:t>
+              </a:r>
+              <a:r>
+                <a:rPr lang="fr-FR" sz="1600" dirty="0" err="1">
+                  <a:latin typeface="Arial" panose="020B0604020202020204" pitchFamily="34" charset="0"/>
+                  <a:cs typeface="Arial" panose="020B0604020202020204" pitchFamily="34" charset="0"/>
+                </a:rPr>
+                <a:t>nbCoups</a:t>
+              </a:r>
+              <a:r>
+                <a:rPr lang="fr-FR" sz="1600" dirty="0">
+                  <a:latin typeface="Arial" panose="020B0604020202020204" pitchFamily="34" charset="0"/>
+                  <a:cs typeface="Arial" panose="020B0604020202020204" pitchFamily="34" charset="0"/>
+                </a:rPr>
+                <a:t> : </a:t>
+              </a:r>
+              <a:r>
+                <a:rPr lang="fr-FR" sz="1600" dirty="0" err="1">
+                  <a:latin typeface="Arial" panose="020B0604020202020204" pitchFamily="34" charset="0"/>
+                  <a:cs typeface="Arial" panose="020B0604020202020204" pitchFamily="34" charset="0"/>
+                </a:rPr>
+                <a:t>int</a:t>
+              </a:r>
+              <a:endParaRPr lang="fr-FR" sz="1600" dirty="0">
+                <a:latin typeface="Arial" panose="020B0604020202020204" pitchFamily="34" charset="0"/>
+                <a:cs typeface="Arial" panose="020B0604020202020204" pitchFamily="34" charset="0"/>
+              </a:endParaRPr>
+            </a:p>
+          </p:txBody>
+        </p:sp>
+        <p:sp>
+          <p:nvSpPr>
+            <p:cNvPr id="23" name="ZoneTexte 22">
+              <a:extLst>
+                <a:ext uri="{FF2B5EF4-FFF2-40B4-BE49-F238E27FC236}">
+                  <a16:creationId xmlns:a16="http://schemas.microsoft.com/office/drawing/2014/main" id="{E5E08043-B0F6-45DD-87A4-82197924EBD9}"/>
+                </a:ext>
+              </a:extLst>
+            </p:cNvPr>
+            <p:cNvSpPr txBox="1"/>
+            <p:nvPr/>
+          </p:nvSpPr>
+          <p:spPr>
+            <a:xfrm>
+              <a:off x="734400" y="1837913"/>
+              <a:ext cx="2276585" cy="3539430"/>
+            </a:xfrm>
+            <a:prstGeom prst="rect">
+              <a:avLst/>
+            </a:prstGeom>
+            <a:noFill/>
+          </p:spPr>
+          <p:txBody>
+            <a:bodyPr wrap="none" rtlCol="0">
+              <a:spAutoFit/>
+            </a:bodyPr>
+            <a:lstStyle/>
+            <a:p>
+              <a:r>
+                <a:rPr lang="fr-FR" sz="1600" dirty="0">
+                  <a:latin typeface="Arial" panose="020B0604020202020204" pitchFamily="34" charset="0"/>
+                  <a:cs typeface="Arial" panose="020B0604020202020204" pitchFamily="34" charset="0"/>
+                </a:rPr>
+                <a:t>+ joueurAtteint2048()</a:t>
+              </a:r>
+            </a:p>
+            <a:p>
+              <a:r>
+                <a:rPr lang="fr-FR" sz="1600" dirty="0">
+                  <a:latin typeface="Arial" panose="020B0604020202020204" pitchFamily="34" charset="0"/>
+                  <a:cs typeface="Arial" panose="020B0604020202020204" pitchFamily="34" charset="0"/>
+                </a:rPr>
+                <a:t>+ </a:t>
+              </a:r>
+              <a:r>
+                <a:rPr lang="fr-FR" sz="1600" dirty="0" err="1">
+                  <a:latin typeface="Arial" panose="020B0604020202020204" pitchFamily="34" charset="0"/>
+                  <a:cs typeface="Arial" panose="020B0604020202020204" pitchFamily="34" charset="0"/>
+                </a:rPr>
+                <a:t>deplacement</a:t>
+              </a:r>
+              <a:r>
+                <a:rPr lang="fr-FR" sz="1600" dirty="0">
+                  <a:latin typeface="Arial" panose="020B0604020202020204" pitchFamily="34" charset="0"/>
+                  <a:cs typeface="Arial" panose="020B0604020202020204" pitchFamily="34" charset="0"/>
+                </a:rPr>
+                <a:t>()</a:t>
+              </a:r>
+            </a:p>
+            <a:p>
+              <a:r>
+                <a:rPr lang="fr-FR" sz="1600" dirty="0">
+                  <a:latin typeface="Arial" panose="020B0604020202020204" pitchFamily="34" charset="0"/>
+                  <a:cs typeface="Arial" panose="020B0604020202020204" pitchFamily="34" charset="0"/>
+                </a:rPr>
+                <a:t>+ </a:t>
+              </a:r>
+              <a:r>
+                <a:rPr lang="fr-FR" sz="1600" dirty="0" err="1">
+                  <a:latin typeface="Arial" panose="020B0604020202020204" pitchFamily="34" charset="0"/>
+                  <a:cs typeface="Arial" panose="020B0604020202020204" pitchFamily="34" charset="0"/>
+                </a:rPr>
+                <a:t>deplacerCase</a:t>
+              </a:r>
+              <a:r>
+                <a:rPr lang="fr-FR" sz="1600" dirty="0">
+                  <a:latin typeface="Arial" panose="020B0604020202020204" pitchFamily="34" charset="0"/>
+                  <a:cs typeface="Arial" panose="020B0604020202020204" pitchFamily="34" charset="0"/>
+                </a:rPr>
+                <a:t>()</a:t>
+              </a:r>
+            </a:p>
+            <a:p>
+              <a:r>
+                <a:rPr lang="fr-FR" sz="1600" dirty="0">
+                  <a:latin typeface="Arial" panose="020B0604020202020204" pitchFamily="34" charset="0"/>
+                  <a:cs typeface="Arial" panose="020B0604020202020204" pitchFamily="34" charset="0"/>
+                </a:rPr>
+                <a:t>+ </a:t>
+              </a:r>
+              <a:r>
+                <a:rPr lang="fr-FR" sz="1600" dirty="0" err="1">
+                  <a:latin typeface="Arial" panose="020B0604020202020204" pitchFamily="34" charset="0"/>
+                  <a:cs typeface="Arial" panose="020B0604020202020204" pitchFamily="34" charset="0"/>
+                </a:rPr>
+                <a:t>fusionCase</a:t>
+              </a:r>
+              <a:r>
+                <a:rPr lang="fr-FR" sz="1600" dirty="0">
+                  <a:latin typeface="Arial" panose="020B0604020202020204" pitchFamily="34" charset="0"/>
+                  <a:cs typeface="Arial" panose="020B0604020202020204" pitchFamily="34" charset="0"/>
+                </a:rPr>
+                <a:t>()</a:t>
+              </a:r>
+            </a:p>
+            <a:p>
+              <a:r>
+                <a:rPr lang="fr-FR" sz="1600" dirty="0">
+                  <a:latin typeface="Arial" panose="020B0604020202020204" pitchFamily="34" charset="0"/>
+                  <a:cs typeface="Arial" panose="020B0604020202020204" pitchFamily="34" charset="0"/>
+                </a:rPr>
+                <a:t>+ </a:t>
+              </a:r>
+              <a:r>
+                <a:rPr lang="fr-FR" sz="1600" dirty="0" err="1">
+                  <a:latin typeface="Arial" panose="020B0604020202020204" pitchFamily="34" charset="0"/>
+                  <a:cs typeface="Arial" panose="020B0604020202020204" pitchFamily="34" charset="0"/>
+                </a:rPr>
+                <a:t>ajoutCase</a:t>
+              </a:r>
+              <a:r>
+                <a:rPr lang="fr-FR" sz="1600" dirty="0">
+                  <a:latin typeface="Arial" panose="020B0604020202020204" pitchFamily="34" charset="0"/>
+                  <a:cs typeface="Arial" panose="020B0604020202020204" pitchFamily="34" charset="0"/>
+                </a:rPr>
+                <a:t>()</a:t>
+              </a:r>
+            </a:p>
+            <a:p>
+              <a:r>
+                <a:rPr lang="fr-FR" sz="1600" dirty="0">
+                  <a:latin typeface="Arial" panose="020B0604020202020204" pitchFamily="34" charset="0"/>
+                  <a:cs typeface="Arial" panose="020B0604020202020204" pitchFamily="34" charset="0"/>
+                </a:rPr>
+                <a:t>+ </a:t>
+              </a:r>
+              <a:r>
+                <a:rPr lang="fr-FR" sz="1600" dirty="0" err="1">
+                  <a:latin typeface="Arial" panose="020B0604020202020204" pitchFamily="34" charset="0"/>
+                  <a:cs typeface="Arial" panose="020B0604020202020204" pitchFamily="34" charset="0"/>
+                </a:rPr>
+                <a:t>gameOver</a:t>
+              </a:r>
+              <a:r>
+                <a:rPr lang="fr-FR" sz="1600" dirty="0">
+                  <a:latin typeface="Arial" panose="020B0604020202020204" pitchFamily="34" charset="0"/>
+                  <a:cs typeface="Arial" panose="020B0604020202020204" pitchFamily="34" charset="0"/>
+                </a:rPr>
+                <a:t>()</a:t>
+              </a:r>
+            </a:p>
+            <a:p>
+              <a:r>
+                <a:rPr lang="fr-FR" sz="1600" dirty="0">
+                  <a:latin typeface="Arial" panose="020B0604020202020204" pitchFamily="34" charset="0"/>
+                  <a:cs typeface="Arial" panose="020B0604020202020204" pitchFamily="34" charset="0"/>
+                </a:rPr>
+                <a:t>+ </a:t>
+              </a:r>
+              <a:r>
+                <a:rPr lang="fr-FR" sz="1600" dirty="0" err="1">
+                  <a:latin typeface="Arial" panose="020B0604020202020204" pitchFamily="34" charset="0"/>
+                  <a:cs typeface="Arial" panose="020B0604020202020204" pitchFamily="34" charset="0"/>
+                </a:rPr>
+                <a:t>deplacementAFaire</a:t>
+              </a:r>
+              <a:r>
+                <a:rPr lang="fr-FR" sz="1600" dirty="0">
+                  <a:latin typeface="Arial" panose="020B0604020202020204" pitchFamily="34" charset="0"/>
+                  <a:cs typeface="Arial" panose="020B0604020202020204" pitchFamily="34" charset="0"/>
+                </a:rPr>
+                <a:t>()</a:t>
+              </a:r>
+            </a:p>
+            <a:p>
+              <a:r>
+                <a:rPr lang="fr-FR" sz="1600" dirty="0">
+                  <a:latin typeface="Arial" panose="020B0604020202020204" pitchFamily="34" charset="0"/>
+                  <a:cs typeface="Arial" panose="020B0604020202020204" pitchFamily="34" charset="0"/>
+                </a:rPr>
+                <a:t>+ </a:t>
+              </a:r>
+              <a:r>
+                <a:rPr lang="fr-FR" sz="1600" dirty="0" err="1">
+                  <a:latin typeface="Arial" panose="020B0604020202020204" pitchFamily="34" charset="0"/>
+                  <a:cs typeface="Arial" panose="020B0604020202020204" pitchFamily="34" charset="0"/>
+                </a:rPr>
+                <a:t>testDeplacement</a:t>
+              </a:r>
+              <a:r>
+                <a:rPr lang="fr-FR" sz="1600" dirty="0">
+                  <a:latin typeface="Arial" panose="020B0604020202020204" pitchFamily="34" charset="0"/>
+                  <a:cs typeface="Arial" panose="020B0604020202020204" pitchFamily="34" charset="0"/>
+                </a:rPr>
+                <a:t>()</a:t>
+              </a:r>
+            </a:p>
+            <a:p>
+              <a:r>
+                <a:rPr lang="fr-FR" sz="1600" dirty="0">
+                  <a:latin typeface="Arial" panose="020B0604020202020204" pitchFamily="34" charset="0"/>
+                  <a:cs typeface="Arial" panose="020B0604020202020204" pitchFamily="34" charset="0"/>
+                </a:rPr>
+                <a:t>+ afficher()</a:t>
+              </a:r>
+            </a:p>
+            <a:p>
+              <a:r>
+                <a:rPr lang="fr-FR" sz="1600" dirty="0">
+                  <a:latin typeface="Arial" panose="020B0604020202020204" pitchFamily="34" charset="0"/>
+                  <a:cs typeface="Arial" panose="020B0604020202020204" pitchFamily="34" charset="0"/>
+                </a:rPr>
+                <a:t>+ </a:t>
+              </a:r>
+              <a:r>
+                <a:rPr lang="fr-FR" sz="1600" dirty="0" err="1">
+                  <a:latin typeface="Arial" panose="020B0604020202020204" pitchFamily="34" charset="0"/>
+                  <a:cs typeface="Arial" panose="020B0604020202020204" pitchFamily="34" charset="0"/>
+                </a:rPr>
+                <a:t>getBestTuile</a:t>
+              </a:r>
+              <a:endParaRPr lang="fr-FR" sz="1600" dirty="0">
+                <a:latin typeface="Arial" panose="020B0604020202020204" pitchFamily="34" charset="0"/>
+                <a:cs typeface="Arial" panose="020B0604020202020204" pitchFamily="34" charset="0"/>
+              </a:endParaRPr>
+            </a:p>
+            <a:p>
+              <a:r>
+                <a:rPr lang="fr-FR" sz="1600" dirty="0">
+                  <a:latin typeface="Arial" panose="020B0604020202020204" pitchFamily="34" charset="0"/>
+                  <a:cs typeface="Arial" panose="020B0604020202020204" pitchFamily="34" charset="0"/>
+                </a:rPr>
+                <a:t>+ </a:t>
+              </a:r>
+              <a:r>
+                <a:rPr lang="fr-FR" sz="1600" dirty="0" err="1">
+                  <a:latin typeface="Arial" panose="020B0604020202020204" pitchFamily="34" charset="0"/>
+                  <a:cs typeface="Arial" panose="020B0604020202020204" pitchFamily="34" charset="0"/>
+                </a:rPr>
+                <a:t>getScore</a:t>
+              </a:r>
+              <a:r>
+                <a:rPr lang="fr-FR" sz="1600" dirty="0">
+                  <a:latin typeface="Arial" panose="020B0604020202020204" pitchFamily="34" charset="0"/>
+                  <a:cs typeface="Arial" panose="020B0604020202020204" pitchFamily="34" charset="0"/>
+                </a:rPr>
+                <a:t>()</a:t>
+              </a:r>
+            </a:p>
+            <a:p>
+              <a:r>
+                <a:rPr lang="fr-FR" sz="1600" dirty="0">
+                  <a:latin typeface="Arial" panose="020B0604020202020204" pitchFamily="34" charset="0"/>
+                  <a:cs typeface="Arial" panose="020B0604020202020204" pitchFamily="34" charset="0"/>
+                </a:rPr>
+                <a:t>+ </a:t>
+              </a:r>
+              <a:r>
+                <a:rPr lang="fr-FR" sz="1600" dirty="0" err="1">
+                  <a:latin typeface="Arial" panose="020B0604020202020204" pitchFamily="34" charset="0"/>
+                  <a:cs typeface="Arial" panose="020B0604020202020204" pitchFamily="34" charset="0"/>
+                </a:rPr>
+                <a:t>getNbCoups</a:t>
+              </a:r>
+              <a:r>
+                <a:rPr lang="fr-FR" sz="1600" dirty="0">
+                  <a:latin typeface="Arial" panose="020B0604020202020204" pitchFamily="34" charset="0"/>
+                  <a:cs typeface="Arial" panose="020B0604020202020204" pitchFamily="34" charset="0"/>
+                </a:rPr>
+                <a:t>()</a:t>
+              </a:r>
+            </a:p>
+            <a:p>
+              <a:r>
+                <a:rPr lang="fr-FR" sz="1600" dirty="0">
+                  <a:latin typeface="Arial" panose="020B0604020202020204" pitchFamily="34" charset="0"/>
+                  <a:cs typeface="Arial" panose="020B0604020202020204" pitchFamily="34" charset="0"/>
+                </a:rPr>
+                <a:t>+ getatteint2048()</a:t>
+              </a:r>
+            </a:p>
+            <a:p>
+              <a:r>
+                <a:rPr lang="fr-FR" sz="1600" dirty="0">
+                  <a:latin typeface="Arial" panose="020B0604020202020204" pitchFamily="34" charset="0"/>
+                  <a:cs typeface="Arial" panose="020B0604020202020204" pitchFamily="34" charset="0"/>
+                </a:rPr>
+                <a:t>+ setatteint2048()</a:t>
+              </a:r>
+            </a:p>
+          </p:txBody>
+        </p:sp>
+      </p:grpSp>
+      <p:sp>
+        <p:nvSpPr>
+          <p:cNvPr id="28" name="ZoneTexte 27">
+            <a:extLst>
+              <a:ext uri="{FF2B5EF4-FFF2-40B4-BE49-F238E27FC236}">
+                <a16:creationId xmlns:a16="http://schemas.microsoft.com/office/drawing/2014/main" id="{9D98530D-F9E2-4715-AEED-ABFA29B5920A}"/>
+              </a:ext>
+            </a:extLst>
+          </p:cNvPr>
+          <p:cNvSpPr txBox="1"/>
+          <p:nvPr/>
+        </p:nvSpPr>
         <p:spPr>
           <a:xfrm>
-            <a:off x="1460166" y="2395331"/>
-            <a:ext cx="1922400" cy="0"/>
-          </a:xfrm>
-          <a:prstGeom prst="line">
-            <a:avLst/>
-          </a:prstGeom>
-          <a:ln w="12700">
-            <a:solidFill>
-              <a:schemeClr val="tx1"/>
-            </a:solidFill>
-          </a:ln>
-        </p:spPr>
-        <p:style>
-          <a:lnRef idx="1">
-            <a:schemeClr val="accent1"/>
-          </a:lnRef>
-          <a:fillRef idx="0">
-            <a:schemeClr val="accent1"/>
-          </a:fillRef>
-          <a:effectRef idx="0">
-            <a:schemeClr val="accent1"/>
-          </a:effectRef>
-          <a:fontRef idx="minor">
-            <a:schemeClr val="tx1"/>
-          </a:fontRef>
-        </p:style>
-      </p:cxnSp>
-      <p:sp>
-        <p:nvSpPr>
-          <p:cNvPr id="21" name="ZoneTexte 20">
-            <a:extLst>
-              <a:ext uri="{FF2B5EF4-FFF2-40B4-BE49-F238E27FC236}">
-                <a16:creationId xmlns:a16="http://schemas.microsoft.com/office/drawing/2014/main" id="{77DA9FB0-3C93-43A2-B171-E6DE7E6414B4}"/>
-              </a:ext>
-            </a:extLst>
-          </p:cNvPr>
-          <p:cNvSpPr txBox="1"/>
-          <p:nvPr/>
-        </p:nvSpPr>
-        <p:spPr>
-          <a:xfrm>
-            <a:off x="1464197" y="1580388"/>
-            <a:ext cx="1922320" cy="830997"/>
+            <a:off x="5527060" y="1946047"/>
+            <a:ext cx="1173719" cy="338554"/>
           </a:xfrm>
           <a:prstGeom prst="rect">
             <a:avLst/>
@@ -3905,285 +4346,10 @@
           <a:noFill/>
         </p:spPr>
         <p:txBody>
-          <a:bodyPr wrap="square" rtlCol="0">
-            <a:spAutoFit/>
-          </a:bodyPr>
-          <a:lstStyle/>
-          <a:p>
-            <a:pPr marL="285750" indent="-285750">
-              <a:buFontTx/>
-              <a:buChar char="-"/>
-            </a:pPr>
-            <a:r>
-              <a:rPr lang="fr-FR" sz="1600" dirty="0" err="1">
-                <a:latin typeface="Arial" panose="020B0604020202020204" pitchFamily="34" charset="0"/>
-                <a:cs typeface="Arial" panose="020B0604020202020204" pitchFamily="34" charset="0"/>
-              </a:rPr>
-              <a:t>enCours</a:t>
-            </a:r>
-            <a:r>
-              <a:rPr lang="fr-FR" sz="1600" dirty="0">
-                <a:latin typeface="Arial" panose="020B0604020202020204" pitchFamily="34" charset="0"/>
-                <a:cs typeface="Arial" panose="020B0604020202020204" pitchFamily="34" charset="0"/>
-              </a:rPr>
-              <a:t> : </a:t>
-            </a:r>
-            <a:r>
-              <a:rPr lang="fr-FR" sz="1600" dirty="0" err="1">
-                <a:latin typeface="Arial" panose="020B0604020202020204" pitchFamily="34" charset="0"/>
-                <a:cs typeface="Arial" panose="020B0604020202020204" pitchFamily="34" charset="0"/>
-              </a:rPr>
-              <a:t>bool</a:t>
-            </a:r>
-            <a:endParaRPr lang="fr-FR" sz="1600" dirty="0">
-              <a:latin typeface="Arial" panose="020B0604020202020204" pitchFamily="34" charset="0"/>
-              <a:cs typeface="Arial" panose="020B0604020202020204" pitchFamily="34" charset="0"/>
-            </a:endParaRPr>
-          </a:p>
-          <a:p>
-            <a:pPr marL="285750" indent="-285750">
-              <a:buFontTx/>
-              <a:buChar char="-"/>
-            </a:pPr>
-            <a:r>
-              <a:rPr lang="fr-FR" sz="1600" dirty="0" err="1">
-                <a:latin typeface="Arial" panose="020B0604020202020204" pitchFamily="34" charset="0"/>
-                <a:cs typeface="Arial" panose="020B0604020202020204" pitchFamily="34" charset="0"/>
-              </a:rPr>
-              <a:t>estGagne</a:t>
-            </a:r>
-            <a:r>
-              <a:rPr lang="fr-FR" sz="1600" dirty="0">
-                <a:latin typeface="Arial" panose="020B0604020202020204" pitchFamily="34" charset="0"/>
-                <a:cs typeface="Arial" panose="020B0604020202020204" pitchFamily="34" charset="0"/>
-              </a:rPr>
-              <a:t> : </a:t>
-            </a:r>
-            <a:r>
-              <a:rPr lang="fr-FR" sz="1600" dirty="0" err="1">
-                <a:latin typeface="Arial" panose="020B0604020202020204" pitchFamily="34" charset="0"/>
-                <a:cs typeface="Arial" panose="020B0604020202020204" pitchFamily="34" charset="0"/>
-              </a:rPr>
-              <a:t>bool</a:t>
-            </a:r>
-            <a:endParaRPr lang="fr-FR" sz="1600" dirty="0">
-              <a:latin typeface="Arial" panose="020B0604020202020204" pitchFamily="34" charset="0"/>
-              <a:cs typeface="Arial" panose="020B0604020202020204" pitchFamily="34" charset="0"/>
-            </a:endParaRPr>
-          </a:p>
-          <a:p>
-            <a:pPr marL="285750" indent="-285750">
-              <a:buFontTx/>
-              <a:buChar char="-"/>
-            </a:pPr>
-            <a:r>
-              <a:rPr lang="fr-FR" sz="1600" dirty="0" err="1">
-                <a:latin typeface="Arial" panose="020B0604020202020204" pitchFamily="34" charset="0"/>
-                <a:cs typeface="Arial" panose="020B0604020202020204" pitchFamily="34" charset="0"/>
-              </a:rPr>
-              <a:t>estPerdu</a:t>
-            </a:r>
-            <a:r>
-              <a:rPr lang="fr-FR" sz="1600" dirty="0">
-                <a:latin typeface="Arial" panose="020B0604020202020204" pitchFamily="34" charset="0"/>
-                <a:cs typeface="Arial" panose="020B0604020202020204" pitchFamily="34" charset="0"/>
-              </a:rPr>
-              <a:t> : </a:t>
-            </a:r>
-            <a:r>
-              <a:rPr lang="fr-FR" sz="1600" dirty="0" err="1">
-                <a:latin typeface="Arial" panose="020B0604020202020204" pitchFamily="34" charset="0"/>
-                <a:cs typeface="Arial" panose="020B0604020202020204" pitchFamily="34" charset="0"/>
-              </a:rPr>
-              <a:t>bool</a:t>
-            </a:r>
-            <a:endParaRPr lang="fr-FR" sz="1600" dirty="0">
-              <a:latin typeface="Arial" panose="020B0604020202020204" pitchFamily="34" charset="0"/>
-              <a:cs typeface="Arial" panose="020B0604020202020204" pitchFamily="34" charset="0"/>
-            </a:endParaRPr>
-          </a:p>
-        </p:txBody>
-      </p:sp>
-      <p:sp>
-        <p:nvSpPr>
-          <p:cNvPr id="23" name="ZoneTexte 22">
-            <a:extLst>
-              <a:ext uri="{FF2B5EF4-FFF2-40B4-BE49-F238E27FC236}">
-                <a16:creationId xmlns:a16="http://schemas.microsoft.com/office/drawing/2014/main" id="{E5E08043-B0F6-45DD-87A4-82197924EBD9}"/>
-              </a:ext>
-            </a:extLst>
-          </p:cNvPr>
-          <p:cNvSpPr txBox="1"/>
-          <p:nvPr/>
-        </p:nvSpPr>
-        <p:spPr>
-          <a:xfrm>
-            <a:off x="1456092" y="2386921"/>
-            <a:ext cx="1715021" cy="1323439"/>
-          </a:xfrm>
-          <a:prstGeom prst="rect">
-            <a:avLst/>
-          </a:prstGeom>
-          <a:noFill/>
-        </p:spPr>
-        <p:txBody>
           <a:bodyPr wrap="none" rtlCol="0">
             <a:spAutoFit/>
           </a:bodyPr>
           <a:lstStyle/>
-          <a:p>
-            <a:r>
-              <a:rPr lang="fr-FR" sz="1600" dirty="0">
-                <a:latin typeface="Arial" panose="020B0604020202020204" pitchFamily="34" charset="0"/>
-                <a:cs typeface="Arial" panose="020B0604020202020204" pitchFamily="34" charset="0"/>
-              </a:rPr>
-              <a:t>+ </a:t>
-            </a:r>
-            <a:r>
-              <a:rPr lang="fr-FR" sz="1600" dirty="0" err="1">
-                <a:latin typeface="Arial" panose="020B0604020202020204" pitchFamily="34" charset="0"/>
-                <a:cs typeface="Arial" panose="020B0604020202020204" pitchFamily="34" charset="0"/>
-              </a:rPr>
-              <a:t>testGagne</a:t>
-            </a:r>
-            <a:r>
-              <a:rPr lang="fr-FR" sz="1600" dirty="0">
-                <a:latin typeface="Arial" panose="020B0604020202020204" pitchFamily="34" charset="0"/>
-                <a:cs typeface="Arial" panose="020B0604020202020204" pitchFamily="34" charset="0"/>
-              </a:rPr>
-              <a:t>()</a:t>
-            </a:r>
-          </a:p>
-          <a:p>
-            <a:r>
-              <a:rPr lang="fr-FR" sz="1600" dirty="0">
-                <a:latin typeface="Arial" panose="020B0604020202020204" pitchFamily="34" charset="0"/>
-                <a:cs typeface="Arial" panose="020B0604020202020204" pitchFamily="34" charset="0"/>
-              </a:rPr>
-              <a:t>+ </a:t>
-            </a:r>
-            <a:r>
-              <a:rPr lang="fr-FR" sz="1600" dirty="0" err="1">
-                <a:latin typeface="Arial" panose="020B0604020202020204" pitchFamily="34" charset="0"/>
-                <a:cs typeface="Arial" panose="020B0604020202020204" pitchFamily="34" charset="0"/>
-              </a:rPr>
-              <a:t>testPerdu</a:t>
-            </a:r>
-            <a:r>
-              <a:rPr lang="fr-FR" sz="1600" dirty="0">
-                <a:latin typeface="Arial" panose="020B0604020202020204" pitchFamily="34" charset="0"/>
-                <a:cs typeface="Arial" panose="020B0604020202020204" pitchFamily="34" charset="0"/>
-              </a:rPr>
-              <a:t>()</a:t>
-            </a:r>
-          </a:p>
-          <a:p>
-            <a:r>
-              <a:rPr lang="fr-FR" sz="1600" dirty="0">
-                <a:latin typeface="Arial" panose="020B0604020202020204" pitchFamily="34" charset="0"/>
-                <a:cs typeface="Arial" panose="020B0604020202020204" pitchFamily="34" charset="0"/>
-              </a:rPr>
-              <a:t>+ </a:t>
-            </a:r>
-            <a:r>
-              <a:rPr lang="fr-FR" sz="1600" dirty="0" err="1">
-                <a:latin typeface="Arial" panose="020B0604020202020204" pitchFamily="34" charset="0"/>
-                <a:cs typeface="Arial" panose="020B0604020202020204" pitchFamily="34" charset="0"/>
-              </a:rPr>
-              <a:t>testCaseVide</a:t>
-            </a:r>
-            <a:r>
-              <a:rPr lang="fr-FR" sz="1600" dirty="0">
-                <a:latin typeface="Arial" panose="020B0604020202020204" pitchFamily="34" charset="0"/>
-                <a:cs typeface="Arial" panose="020B0604020202020204" pitchFamily="34" charset="0"/>
-              </a:rPr>
-              <a:t>()</a:t>
-            </a:r>
-          </a:p>
-          <a:p>
-            <a:r>
-              <a:rPr lang="fr-FR" sz="1600" dirty="0">
-                <a:latin typeface="Arial" panose="020B0604020202020204" pitchFamily="34" charset="0"/>
-                <a:cs typeface="Arial" panose="020B0604020202020204" pitchFamily="34" charset="0"/>
-              </a:rPr>
-              <a:t>+ </a:t>
-            </a:r>
-            <a:r>
-              <a:rPr lang="fr-FR" sz="1600" dirty="0" err="1">
-                <a:latin typeface="Arial" panose="020B0604020202020204" pitchFamily="34" charset="0"/>
-                <a:cs typeface="Arial" panose="020B0604020202020204" pitchFamily="34" charset="0"/>
-              </a:rPr>
-              <a:t>deplacement</a:t>
-            </a:r>
-            <a:r>
-              <a:rPr lang="fr-FR" sz="1600" dirty="0">
-                <a:latin typeface="Arial" panose="020B0604020202020204" pitchFamily="34" charset="0"/>
-                <a:cs typeface="Arial" panose="020B0604020202020204" pitchFamily="34" charset="0"/>
-              </a:rPr>
-              <a:t>()</a:t>
-            </a:r>
-          </a:p>
-          <a:p>
-            <a:r>
-              <a:rPr lang="fr-FR" sz="1600" dirty="0">
-                <a:latin typeface="Arial" panose="020B0604020202020204" pitchFamily="34" charset="0"/>
-                <a:cs typeface="Arial" panose="020B0604020202020204" pitchFamily="34" charset="0"/>
-              </a:rPr>
-              <a:t>+ afficher()</a:t>
-            </a:r>
-          </a:p>
-        </p:txBody>
-      </p:sp>
-      <p:sp>
-        <p:nvSpPr>
-          <p:cNvPr id="28" name="ZoneTexte 27">
-            <a:extLst>
-              <a:ext uri="{FF2B5EF4-FFF2-40B4-BE49-F238E27FC236}">
-                <a16:creationId xmlns:a16="http://schemas.microsoft.com/office/drawing/2014/main" id="{9D98530D-F9E2-4715-AEED-ABFA29B5920A}"/>
-              </a:ext>
-            </a:extLst>
-          </p:cNvPr>
-          <p:cNvSpPr txBox="1"/>
-          <p:nvPr/>
-        </p:nvSpPr>
-        <p:spPr>
-          <a:xfrm>
-            <a:off x="5527060" y="1946047"/>
-            <a:ext cx="1673856" cy="584775"/>
-          </a:xfrm>
-          <a:prstGeom prst="rect">
-            <a:avLst/>
-          </a:prstGeom>
-          <a:noFill/>
-        </p:spPr>
-        <p:txBody>
-          <a:bodyPr wrap="none" rtlCol="0">
-            <a:spAutoFit/>
-          </a:bodyPr>
-          <a:lstStyle/>
-          <a:p>
-            <a:r>
-              <a:rPr lang="fr-FR" sz="1600" dirty="0">
-                <a:latin typeface="Arial" panose="020B0604020202020204" pitchFamily="34" charset="0"/>
-                <a:cs typeface="Arial" panose="020B0604020202020204" pitchFamily="34" charset="0"/>
-              </a:rPr>
-              <a:t>+ </a:t>
-            </a:r>
-            <a:r>
-              <a:rPr lang="fr-FR" sz="1600" i="1" dirty="0" err="1">
-                <a:latin typeface="Arial" panose="020B0604020202020204" pitchFamily="34" charset="0"/>
-                <a:cs typeface="Arial" panose="020B0604020202020204" pitchFamily="34" charset="0"/>
-              </a:rPr>
-              <a:t>deplacement</a:t>
-            </a:r>
-            <a:r>
-              <a:rPr lang="fr-FR" sz="1600" dirty="0">
-                <a:latin typeface="Arial" panose="020B0604020202020204" pitchFamily="34" charset="0"/>
-                <a:cs typeface="Arial" panose="020B0604020202020204" pitchFamily="34" charset="0"/>
-              </a:rPr>
-              <a:t>()</a:t>
-            </a:r>
-          </a:p>
           <a:p>
             <a:r>
               <a:rPr lang="fr-FR" sz="1600" dirty="0">
@@ -4303,7 +4469,7 @@
         <p:spPr>
           <a:xfrm>
             <a:off x="6889417" y="3559746"/>
-            <a:ext cx="1420582" cy="338554"/>
+            <a:ext cx="1258678" cy="338554"/>
           </a:xfrm>
           <a:prstGeom prst="rect">
             <a:avLst/>
@@ -4316,16 +4482,12 @@
           </a:bodyPr>
           <a:lstStyle/>
           <a:p>
-            <a:pPr marL="285750" indent="-285750">
-              <a:buFontTx/>
-              <a:buChar char="-"/>
-            </a:pPr>
             <a:r>
               <a:rPr lang="fr-FR" sz="1600" dirty="0">
                 <a:latin typeface="Arial" panose="020B0604020202020204" pitchFamily="34" charset="0"/>
                 <a:cs typeface="Arial" panose="020B0604020202020204" pitchFamily="34" charset="0"/>
               </a:rPr>
-              <a:t>valeur : </a:t>
+              <a:t>- valeur : </a:t>
             </a:r>
             <a:r>
               <a:rPr lang="fr-FR" sz="1600" dirty="0" err="1">
@@ -4400,7 +4562,7 @@
         </p:nvCxnSpPr>
         <p:spPr>
           <a:xfrm>
-            <a:off x="4219502" y="3854175"/>
+            <a:off x="4219502" y="3898800"/>
             <a:ext cx="1930424" cy="0"/>
           </a:xfrm>
           <a:prstGeom prst="line">
@@ -4442,7 +4604,7 @@
         <p:spPr>
           <a:xfrm>
             <a:off x="6881309" y="3894697"/>
-            <a:ext cx="1673856" cy="584775"/>
+            <a:ext cx="1362040" cy="584775"/>
           </a:xfrm>
           <a:prstGeom prst="rect">
             <a:avLst/>
@@ -4460,6 +4622,15 @@
                 <a:latin typeface="Arial" panose="020B0604020202020204" pitchFamily="34" charset="0"/>
                 <a:cs typeface="Arial" panose="020B0604020202020204" pitchFamily="34" charset="0"/>
               </a:rPr>
+              <a:t>+ afficher()</a:t>
+            </a:r>
+          </a:p>
+          <a:p>
+            <a:r>
+              <a:rPr lang="fr-FR" sz="1600" dirty="0">
+                <a:latin typeface="Arial" panose="020B0604020202020204" pitchFamily="34" charset="0"/>
+                <a:cs typeface="Arial" panose="020B0604020202020204" pitchFamily="34" charset="0"/>
+              </a:rPr>
               <a:t>+ </a:t>
             </a:r>
             <a:r>
@@ -4467,7 +4638,7 @@
                 <a:latin typeface="Arial" panose="020B0604020202020204" pitchFamily="34" charset="0"/>
                 <a:cs typeface="Arial" panose="020B0604020202020204" pitchFamily="34" charset="0"/>
               </a:rPr>
-              <a:t>deplacement</a:t>
+              <a:t>getValeur</a:t>
             </a:r>
             <a:r>
               <a:rPr lang="fr-FR" sz="1600" dirty="0">
@@ -4477,15 +4648,6 @@
               <a:t>()</a:t>
             </a:r>
           </a:p>
-          <a:p>
-            <a:r>
-              <a:rPr lang="fr-FR" sz="1600" dirty="0">
-                <a:latin typeface="Arial" panose="020B0604020202020204" pitchFamily="34" charset="0"/>
-                <a:cs typeface="Arial" panose="020B0604020202020204" pitchFamily="34" charset="0"/>
-              </a:rPr>
-              <a:t>+ afficher()</a:t>
-            </a:r>
-          </a:p>
         </p:txBody>
       </p:sp>
       <p:sp>
@@ -4502,8 +4664,8 @@
         </p:nvSpPr>
         <p:spPr>
           <a:xfrm>
-            <a:off x="4227608" y="3850571"/>
-            <a:ext cx="1673856" cy="584775"/>
+            <a:off x="4219501" y="3894697"/>
+            <a:ext cx="1170000" cy="338554"/>
           </a:xfrm>
           <a:prstGeom prst="rect">
             <a:avLst/>
@@ -4515,29 +4677,6 @@
             <a:spAutoFit/>
           </a:bodyPr>
           <a:lstStyle/>
-          <a:p>
-            <a:r>
-              <a:rPr lang="fr-FR" sz="1600" dirty="0">
-                <a:latin typeface="Arial" panose="020B0604020202020204" pitchFamily="34" charset="0"/>
-                <a:cs typeface="Arial" panose="020B0604020202020204" pitchFamily="34" charset="0"/>
-              </a:rPr>
-              <a:t>+ </a:t>
-            </a:r>
-            <a:r>
-              <a:rPr lang="fr-FR" sz="1600" dirty="0" err="1">
-                <a:latin typeface="Arial" panose="020B0604020202020204" pitchFamily="34" charset="0"/>
-                <a:cs typeface="Arial" panose="020B0604020202020204" pitchFamily="34" charset="0"/>
-              </a:rPr>
-              <a:t>deplacement</a:t>
-            </a:r>
-            <a:r>
-              <a:rPr lang="fr-FR" sz="1600" dirty="0">
-                <a:latin typeface="Arial" panose="020B0604020202020204" pitchFamily="34" charset="0"/>
-                <a:cs typeface="Arial" panose="020B0604020202020204" pitchFamily="34" charset="0"/>
-              </a:rPr>
-              <a:t>()</a:t>
-            </a:r>
-          </a:p>
           <a:p>
             <a:r>
               <a:rPr lang="fr-FR" sz="1600" dirty="0">
@@ -4565,8 +4704,8 @@
         </p:nvCxnSpPr>
         <p:spPr>
           <a:xfrm flipV="1">
-            <a:off x="7854629" y="2883877"/>
-            <a:ext cx="0" cy="360000"/>
+            <a:off x="7854629" y="2704773"/>
+            <a:ext cx="0" cy="539104"/>
           </a:xfrm>
           <a:prstGeom prst="line">
             <a:avLst/>
@@ -4607,9 +4746,9 @@
           <p:nvPr/>
         </p:nvCxnSpPr>
         <p:spPr>
-          <a:xfrm flipV="1">
-            <a:off x="5192822" y="2883877"/>
-            <a:ext cx="0" cy="360000"/>
+          <a:xfrm flipH="1" flipV="1">
+            <a:off x="5192820" y="2704773"/>
+            <a:ext cx="2" cy="539104"/>
           </a:xfrm>
           <a:prstGeom prst="line">
             <a:avLst/>
@@ -4649,7 +4788,7 @@
         </p:nvCxnSpPr>
         <p:spPr>
           <a:xfrm flipH="1">
-            <a:off x="7207950" y="2883877"/>
+            <a:off x="7200791" y="2704773"/>
             <a:ext cx="653713" cy="0"/>
           </a:xfrm>
           <a:prstGeom prst="line">
@@ -4690,7 +4829,7 @@
         </p:nvCxnSpPr>
         <p:spPr>
           <a:xfrm flipH="1">
-            <a:off x="5184714" y="2883877"/>
+            <a:off x="5184714" y="2705125"/>
             <a:ext cx="653713" cy="0"/>
           </a:xfrm>
           <a:prstGeom prst="line">
@@ -4731,7 +4870,7 @@
         </p:nvSpPr>
         <p:spPr>
           <a:xfrm>
-            <a:off x="7117950" y="2540322"/>
+            <a:off x="7117950" y="2361218"/>
             <a:ext cx="180000" cy="180000"/>
           </a:xfrm>
           <a:prstGeom prst="triangle">
@@ -4785,7 +4924,7 @@
         </p:nvSpPr>
         <p:spPr>
           <a:xfrm>
-            <a:off x="5748427" y="2540322"/>
+            <a:off x="5748427" y="2361600"/>
             <a:ext cx="180000" cy="180000"/>
           </a:xfrm>
           <a:prstGeom prst="triangle">
@@ -4841,7 +4980,7 @@
         </p:nvCxnSpPr>
         <p:spPr>
           <a:xfrm flipV="1">
-            <a:off x="7207950" y="2720322"/>
+            <a:off x="7207950" y="2541218"/>
             <a:ext cx="0" cy="163555"/>
           </a:xfrm>
           <a:prstGeom prst="line">
@@ -4884,7 +5023,7 @@
         </p:nvCxnSpPr>
         <p:spPr>
           <a:xfrm flipV="1">
-            <a:off x="5838427" y="2720322"/>
+            <a:off x="5838427" y="2541600"/>
             <a:ext cx="0" cy="163555"/>
           </a:xfrm>
           <a:prstGeom prst="line">
@@ -4925,7 +5064,7 @@
         </p:nvSpPr>
         <p:spPr>
           <a:xfrm>
-            <a:off x="7241072" y="2463545"/>
+            <a:off x="7264870" y="2367337"/>
             <a:ext cx="288862" cy="338554"/>
           </a:xfrm>
           <a:prstGeom prst="rect">
@@ -4961,7 +5100,7 @@
         </p:nvSpPr>
         <p:spPr>
           <a:xfrm>
-            <a:off x="5516443" y="2463588"/>
+            <a:off x="5478590" y="2367337"/>
             <a:ext cx="288862" cy="338554"/>
           </a:xfrm>
           <a:prstGeom prst="rect">
@@ -5065,15 +5204,15 @@
             </a:extLst>
           </p:cNvPr>
           <p:cNvCxnSpPr>
-            <a:stCxn id="6" idx="3"/>
+            <a:cxnSpLocks/>
             <a:endCxn id="11" idx="1"/>
           </p:cNvCxnSpPr>
           <p:nvPr/>
         </p:nvCxnSpPr>
         <p:spPr>
           <a:xfrm flipV="1">
-            <a:off x="3386519" y="1899394"/>
-            <a:ext cx="2148649" cy="585960"/>
+            <a:off x="3366890" y="1806431"/>
+            <a:ext cx="2168278" cy="905197"/>
           </a:xfrm>
           <a:prstGeom prst="bentConnector3">
             <a:avLst/>
@@ -5204,7 +5343,7 @@
         </p:nvSpPr>
         <p:spPr>
           <a:xfrm>
-            <a:off x="5297808" y="1616234"/>
+            <a:off x="5297808" y="1499359"/>
             <a:ext cx="287258" cy="338554"/>
           </a:xfrm>
           <a:prstGeom prst="rect">

</xml_diff>